<commit_message>
fix(meeting): prevent inherited bullets in template placeholders
</commit_message>
<xml_diff>
--- a/Meeting/20260907_meeting0830_template/deliverables/Meeting_0830_Template.pptx
+++ b/Meeting/20260907_meeting0830_template/deliverables/Meeting_0830_Template.pptx
@@ -1151,7 +1151,8 @@
           </a:bodyPr>
           <a:lstStyle/>
           <a:p>
-            <a:pPr algn="ctr">
+            <a:pPr algn="ctr" marL="0" indent="0">
+              <a:buNone/>
               <a:defRPr sz="5250" b="1">
                 <a:solidFill>
                   <a:srgbClr val="47171C"/>
@@ -1210,7 +1211,8 @@
           </a:bodyPr>
           <a:lstStyle/>
           <a:p>
-            <a:pPr algn="ctr">
+            <a:pPr algn="ctr" marL="0" indent="0">
+              <a:buNone/>
               <a:defRPr sz="2175" b="0">
                 <a:solidFill>
                   <a:srgbClr val="423C3B"/>
@@ -1329,7 +1331,8 @@
           </a:bodyPr>
           <a:lstStyle/>
           <a:p>
-            <a:pPr algn="ctr">
+            <a:pPr algn="ctr" marL="0" indent="0">
+              <a:buNone/>
               <a:defRPr sz="4950" b="1">
                 <a:solidFill>
                   <a:srgbClr val="47171C"/>
@@ -1418,7 +1421,8 @@
           </a:bodyPr>
           <a:lstStyle/>
           <a:p>
-            <a:pPr algn="ctr">
+            <a:pPr algn="ctr" marL="0" indent="0">
+              <a:buNone/>
               <a:defRPr sz="2550" b="0">
                 <a:solidFill>
                   <a:srgbClr val="423C3B"/>
@@ -1477,7 +1481,8 @@
           </a:bodyPr>
           <a:lstStyle/>
           <a:p>
-            <a:pPr algn="ctr">
+            <a:pPr algn="ctr" marL="0" indent="0">
+              <a:buNone/>
               <a:defRPr sz="2250" b="0">
                 <a:solidFill>
                   <a:srgbClr val="CF8792"/>
@@ -1656,7 +1661,8 @@
           </a:bodyPr>
           <a:lstStyle/>
           <a:p>
-            <a:pPr algn="ctr">
+            <a:pPr algn="ctr" marL="0" indent="0">
+              <a:buNone/>
               <a:defRPr sz="5250" b="1">
                 <a:solidFill>
                   <a:srgbClr val="47171C"/>
@@ -1715,7 +1721,8 @@
           </a:bodyPr>
           <a:lstStyle/>
           <a:p>
-            <a:pPr algn="ctr">
+            <a:pPr algn="ctr" marL="0" indent="0">
+              <a:buNone/>
               <a:defRPr sz="2175" b="0">
                 <a:solidFill>
                   <a:srgbClr val="423C3B"/>
@@ -1834,7 +1841,8 @@
           </a:bodyPr>
           <a:lstStyle/>
           <a:p>
-            <a:pPr algn="ctr">
+            <a:pPr algn="ctr" marL="0" indent="0">
+              <a:buNone/>
               <a:defRPr sz="9900" b="1">
                 <a:solidFill>
                   <a:srgbClr val="CF8792"/>
@@ -1923,7 +1931,8 @@
           </a:bodyPr>
           <a:lstStyle/>
           <a:p>
-            <a:pPr algn="ctr">
+            <a:pPr algn="ctr" marL="0" indent="0">
+              <a:buNone/>
               <a:defRPr sz="3225" b="0">
                 <a:solidFill>
                   <a:srgbClr val="47171C"/>
@@ -2102,7 +2111,8 @@
           </a:bodyPr>
           <a:lstStyle/>
           <a:p>
-            <a:pPr algn="ctr">
+            <a:pPr algn="ctr" marL="0" indent="0">
+              <a:buNone/>
               <a:defRPr sz="5250" b="1">
                 <a:solidFill>
                   <a:srgbClr val="47171C"/>
@@ -2161,7 +2171,8 @@
           </a:bodyPr>
           <a:lstStyle/>
           <a:p>
-            <a:pPr algn="ctr">
+            <a:pPr algn="ctr" marL="0" indent="0">
+              <a:buNone/>
               <a:defRPr sz="2175" b="0">
                 <a:solidFill>
                   <a:srgbClr val="423C3B"/>
@@ -2342,7 +2353,8 @@
           </a:bodyPr>
           <a:lstStyle/>
           <a:p>
-            <a:pPr algn="ctr">
+            <a:pPr algn="ctr" marL="0" indent="0">
+              <a:buNone/>
               <a:defRPr sz="2700" b="1">
                 <a:solidFill>
                   <a:srgbClr val="FCF8F5"/>
@@ -2401,7 +2413,8 @@
           </a:bodyPr>
           <a:lstStyle/>
           <a:p>
-            <a:pPr algn="ctr">
+            <a:pPr algn="ctr" marL="0" indent="0">
+              <a:buNone/>
               <a:defRPr sz="3300" b="1">
                 <a:solidFill>
                   <a:srgbClr val="47171C"/>
@@ -2492,7 +2505,8 @@
           </a:bodyPr>
           <a:lstStyle/>
           <a:p>
-            <a:pPr algn="ctr">
+            <a:pPr algn="ctr" marL="0" indent="0">
+              <a:buNone/>
               <a:defRPr sz="1950" b="0">
                 <a:solidFill>
                   <a:srgbClr val="47171C"/>
@@ -2581,7 +2595,8 @@
           </a:bodyPr>
           <a:lstStyle/>
           <a:p>
-            <a:pPr algn="l">
+            <a:pPr algn="l" marL="0" indent="0">
+              <a:buNone/>
               <a:defRPr sz="2250" b="0">
                 <a:solidFill>
                   <a:srgbClr val="423C3B"/>
@@ -2604,12 +2619,16 @@
             </a:r>
           </a:p>
           <a:p>
+            <a:pPr marL="0" indent="0">
+              <a:buNone/>
+            </a:pPr>
             <a:r>
               <a:t/>
             </a:r>
           </a:p>
           <a:p>
-            <a:pPr algn="l">
+            <a:pPr algn="l" marL="0" indent="0">
+              <a:buNone/>
               <a:defRPr sz="2250" b="0">
                 <a:solidFill>
                   <a:srgbClr val="423C3B"/>
@@ -2632,12 +2651,16 @@
             </a:r>
           </a:p>
           <a:p>
+            <a:pPr marL="0" indent="0">
+              <a:buNone/>
+            </a:pPr>
             <a:r>
               <a:t/>
             </a:r>
           </a:p>
           <a:p>
-            <a:pPr algn="l">
+            <a:pPr algn="l" marL="0" indent="0">
+              <a:buNone/>
               <a:defRPr sz="2250" b="0">
                 <a:solidFill>
                   <a:srgbClr val="423C3B"/>
@@ -2758,7 +2781,8 @@
           </a:bodyPr>
           <a:lstStyle/>
           <a:p>
-            <a:pPr algn="ctr">
+            <a:pPr algn="ctr" marL="0" indent="0">
+              <a:buNone/>
               <a:defRPr sz="2700" b="1">
                 <a:solidFill>
                   <a:srgbClr val="FCF8F5"/>
@@ -2817,7 +2841,8 @@
           </a:bodyPr>
           <a:lstStyle/>
           <a:p>
-            <a:pPr algn="ctr">
+            <a:pPr algn="ctr" marL="0" indent="0">
+              <a:buNone/>
               <a:defRPr sz="3300" b="1">
                 <a:solidFill>
                   <a:srgbClr val="47171C"/>
@@ -2908,7 +2933,8 @@
           </a:bodyPr>
           <a:lstStyle/>
           <a:p>
-            <a:pPr algn="ctr">
+            <a:pPr algn="ctr" marL="0" indent="0">
+              <a:buNone/>
               <a:defRPr sz="1950" b="0">
                 <a:solidFill>
                   <a:srgbClr val="47171C"/>
@@ -2997,7 +3023,8 @@
           </a:bodyPr>
           <a:lstStyle/>
           <a:p>
-            <a:pPr algn="l">
+            <a:pPr algn="l" marL="0" indent="0">
+              <a:buNone/>
               <a:defRPr sz="2250" b="0">
                 <a:solidFill>
                   <a:srgbClr val="423C3B"/>
@@ -3020,12 +3047,16 @@
             </a:r>
           </a:p>
           <a:p>
+            <a:pPr marL="0" indent="0">
+              <a:buNone/>
+            </a:pPr>
             <a:r>
               <a:t/>
             </a:r>
           </a:p>
           <a:p>
-            <a:pPr algn="l">
+            <a:pPr algn="l" marL="0" indent="0">
+              <a:buNone/>
               <a:defRPr sz="2250" b="0">
                 <a:solidFill>
                   <a:srgbClr val="423C3B"/>
@@ -3048,12 +3079,16 @@
             </a:r>
           </a:p>
           <a:p>
+            <a:pPr marL="0" indent="0">
+              <a:buNone/>
+            </a:pPr>
             <a:r>
               <a:t/>
             </a:r>
           </a:p>
           <a:p>
-            <a:pPr algn="l">
+            <a:pPr algn="l" marL="0" indent="0">
+              <a:buNone/>
               <a:defRPr sz="2250" b="0">
                 <a:solidFill>
                   <a:srgbClr val="423C3B"/>
@@ -3174,7 +3209,8 @@
           </a:bodyPr>
           <a:lstStyle/>
           <a:p>
-            <a:pPr algn="ctr">
+            <a:pPr algn="ctr" marL="0" indent="0">
+              <a:buNone/>
               <a:defRPr sz="2700" b="1">
                 <a:solidFill>
                   <a:srgbClr val="FCF8F5"/>
@@ -3233,7 +3269,8 @@
           </a:bodyPr>
           <a:lstStyle/>
           <a:p>
-            <a:pPr algn="ctr">
+            <a:pPr algn="ctr" marL="0" indent="0">
+              <a:buNone/>
               <a:defRPr sz="3300" b="1">
                 <a:solidFill>
                   <a:srgbClr val="47171C"/>
@@ -3324,7 +3361,8 @@
           </a:bodyPr>
           <a:lstStyle/>
           <a:p>
-            <a:pPr algn="ctr">
+            <a:pPr algn="ctr" marL="0" indent="0">
+              <a:buNone/>
               <a:defRPr sz="1950" b="0">
                 <a:solidFill>
                   <a:srgbClr val="47171C"/>
@@ -3413,7 +3451,8 @@
           </a:bodyPr>
           <a:lstStyle/>
           <a:p>
-            <a:pPr algn="l">
+            <a:pPr algn="l" marL="0" indent="0">
+              <a:buNone/>
               <a:defRPr sz="2250" b="0">
                 <a:solidFill>
                   <a:srgbClr val="423C3B"/>
@@ -3436,12 +3475,16 @@
             </a:r>
           </a:p>
           <a:p>
+            <a:pPr marL="0" indent="0">
+              <a:buNone/>
+            </a:pPr>
             <a:r>
               <a:t/>
             </a:r>
           </a:p>
           <a:p>
-            <a:pPr algn="l">
+            <a:pPr algn="l" marL="0" indent="0">
+              <a:buNone/>
               <a:defRPr sz="2250" b="0">
                 <a:solidFill>
                   <a:srgbClr val="423C3B"/>
@@ -3464,12 +3507,16 @@
             </a:r>
           </a:p>
           <a:p>
+            <a:pPr marL="0" indent="0">
+              <a:buNone/>
+            </a:pPr>
             <a:r>
               <a:t/>
             </a:r>
           </a:p>
           <a:p>
-            <a:pPr algn="l">
+            <a:pPr algn="l" marL="0" indent="0">
+              <a:buNone/>
               <a:defRPr sz="2250" b="0">
                 <a:solidFill>
                   <a:srgbClr val="423C3B"/>
@@ -3648,7 +3695,8 @@
           </a:bodyPr>
           <a:lstStyle/>
           <a:p>
-            <a:pPr algn="ctr">
+            <a:pPr algn="ctr" marL="0" indent="0">
+              <a:buNone/>
               <a:defRPr sz="5250" b="1">
                 <a:solidFill>
                   <a:srgbClr val="47171C"/>
@@ -3707,7 +3755,8 @@
           </a:bodyPr>
           <a:lstStyle/>
           <a:p>
-            <a:pPr algn="ctr">
+            <a:pPr algn="ctr" marL="0" indent="0">
+              <a:buNone/>
               <a:defRPr sz="2175" b="0">
                 <a:solidFill>
                   <a:srgbClr val="423C3B"/>
@@ -3888,7 +3937,8 @@
           </a:bodyPr>
           <a:lstStyle/>
           <a:p>
-            <a:pPr algn="ctr">
+            <a:pPr algn="ctr" marL="0" indent="0">
+              <a:buNone/>
               <a:defRPr sz="2700" b="1">
                 <a:solidFill>
                   <a:srgbClr val="FCF8F5"/>
@@ -3947,7 +3997,8 @@
           </a:bodyPr>
           <a:lstStyle/>
           <a:p>
-            <a:pPr algn="ctr">
+            <a:pPr algn="ctr" marL="0" indent="0">
+              <a:buNone/>
               <a:defRPr sz="2775" b="1">
                 <a:solidFill>
                   <a:srgbClr val="47171C"/>
@@ -4036,7 +4087,8 @@
           </a:bodyPr>
           <a:lstStyle/>
           <a:p>
-            <a:pPr algn="ctr">
+            <a:pPr algn="ctr" marL="0" indent="0">
+              <a:buNone/>
               <a:defRPr sz="2100" b="0">
                 <a:solidFill>
                   <a:srgbClr val="423C3B"/>
@@ -4059,7 +4111,8 @@
             </a:r>
           </a:p>
           <a:p>
-            <a:pPr algn="ctr">
+            <a:pPr algn="ctr" marL="0" indent="0">
+              <a:buNone/>
               <a:defRPr sz="2100" b="0">
                 <a:solidFill>
                   <a:srgbClr val="423C3B"/>
@@ -4210,7 +4263,8 @@
           </a:bodyPr>
           <a:lstStyle/>
           <a:p>
-            <a:pPr algn="ctr">
+            <a:pPr algn="ctr" marL="0" indent="0">
+              <a:buNone/>
               <a:defRPr sz="2700" b="1">
                 <a:solidFill>
                   <a:srgbClr val="FCF8F5"/>
@@ -4269,7 +4323,8 @@
           </a:bodyPr>
           <a:lstStyle/>
           <a:p>
-            <a:pPr algn="ctr">
+            <a:pPr algn="ctr" marL="0" indent="0">
+              <a:buNone/>
               <a:defRPr sz="2775" b="1">
                 <a:solidFill>
                   <a:srgbClr val="47171C"/>
@@ -4358,7 +4413,8 @@
           </a:bodyPr>
           <a:lstStyle/>
           <a:p>
-            <a:pPr algn="ctr">
+            <a:pPr algn="ctr" marL="0" indent="0">
+              <a:buNone/>
               <a:defRPr sz="2100" b="0">
                 <a:solidFill>
                   <a:srgbClr val="423C3B"/>
@@ -4381,7 +4437,8 @@
             </a:r>
           </a:p>
           <a:p>
-            <a:pPr algn="ctr">
+            <a:pPr algn="ctr" marL="0" indent="0">
+              <a:buNone/>
               <a:defRPr sz="2100" b="0">
                 <a:solidFill>
                   <a:srgbClr val="423C3B"/>
@@ -4532,7 +4589,8 @@
           </a:bodyPr>
           <a:lstStyle/>
           <a:p>
-            <a:pPr algn="ctr">
+            <a:pPr algn="ctr" marL="0" indent="0">
+              <a:buNone/>
               <a:defRPr sz="2700" b="1">
                 <a:solidFill>
                   <a:srgbClr val="FCF8F5"/>
@@ -4591,7 +4649,8 @@
           </a:bodyPr>
           <a:lstStyle/>
           <a:p>
-            <a:pPr algn="ctr">
+            <a:pPr algn="ctr" marL="0" indent="0">
+              <a:buNone/>
               <a:defRPr sz="2775" b="1">
                 <a:solidFill>
                   <a:srgbClr val="47171C"/>
@@ -4680,7 +4739,8 @@
           </a:bodyPr>
           <a:lstStyle/>
           <a:p>
-            <a:pPr algn="ctr">
+            <a:pPr algn="ctr" marL="0" indent="0">
+              <a:buNone/>
               <a:defRPr sz="2100" b="0">
                 <a:solidFill>
                   <a:srgbClr val="423C3B"/>
@@ -4703,7 +4763,8 @@
             </a:r>
           </a:p>
           <a:p>
-            <a:pPr algn="ctr">
+            <a:pPr algn="ctr" marL="0" indent="0">
+              <a:buNone/>
               <a:defRPr sz="2100" b="0">
                 <a:solidFill>
                   <a:srgbClr val="423C3B"/>
@@ -4854,7 +4915,8 @@
           </a:bodyPr>
           <a:lstStyle/>
           <a:p>
-            <a:pPr algn="ctr">
+            <a:pPr algn="ctr" marL="0" indent="0">
+              <a:buNone/>
               <a:defRPr sz="2700" b="1">
                 <a:solidFill>
                   <a:srgbClr val="FCF8F5"/>
@@ -4913,7 +4975,8 @@
           </a:bodyPr>
           <a:lstStyle/>
           <a:p>
-            <a:pPr algn="ctr">
+            <a:pPr algn="ctr" marL="0" indent="0">
+              <a:buNone/>
               <a:defRPr sz="2775" b="1">
                 <a:solidFill>
                   <a:srgbClr val="47171C"/>
@@ -5002,7 +5065,8 @@
           </a:bodyPr>
           <a:lstStyle/>
           <a:p>
-            <a:pPr algn="ctr">
+            <a:pPr algn="ctr" marL="0" indent="0">
+              <a:buNone/>
               <a:defRPr sz="2100" b="0">
                 <a:solidFill>
                   <a:srgbClr val="423C3B"/>
@@ -5025,7 +5089,8 @@
             </a:r>
           </a:p>
           <a:p>
-            <a:pPr algn="ctr">
+            <a:pPr algn="ctr" marL="0" indent="0">
+              <a:buNone/>
               <a:defRPr sz="2100" b="0">
                 <a:solidFill>
                   <a:srgbClr val="423C3B"/>
@@ -5146,7 +5211,8 @@
           </a:bodyPr>
           <a:lstStyle/>
           <a:p>
-            <a:pPr algn="ctr">
+            <a:pPr algn="ctr" marL="0" indent="0">
+              <a:buNone/>
               <a:defRPr sz="2700" b="1">
                 <a:solidFill>
                   <a:srgbClr val="FCF8F5"/>
@@ -5205,7 +5271,8 @@
           </a:bodyPr>
           <a:lstStyle/>
           <a:p>
-            <a:pPr algn="ctr">
+            <a:pPr algn="ctr" marL="0" indent="0">
+              <a:buNone/>
               <a:defRPr sz="2775" b="1">
                 <a:solidFill>
                   <a:srgbClr val="47171C"/>
@@ -5294,7 +5361,8 @@
           </a:bodyPr>
           <a:lstStyle/>
           <a:p>
-            <a:pPr algn="ctr">
+            <a:pPr algn="ctr" marL="0" indent="0">
+              <a:buNone/>
               <a:defRPr sz="2100" b="0">
                 <a:solidFill>
                   <a:srgbClr val="423C3B"/>
@@ -5317,7 +5385,8 @@
             </a:r>
           </a:p>
           <a:p>
-            <a:pPr algn="ctr">
+            <a:pPr algn="ctr" marL="0" indent="0">
+              <a:buNone/>
               <a:defRPr sz="2100" b="0">
                 <a:solidFill>
                   <a:srgbClr val="423C3B"/>
@@ -5438,7 +5507,8 @@
           </a:bodyPr>
           <a:lstStyle/>
           <a:p>
-            <a:pPr algn="ctr">
+            <a:pPr algn="ctr" marL="0" indent="0">
+              <a:buNone/>
               <a:defRPr sz="2700" b="1">
                 <a:solidFill>
                   <a:srgbClr val="FCF8F5"/>
@@ -5497,7 +5567,8 @@
           </a:bodyPr>
           <a:lstStyle/>
           <a:p>
-            <a:pPr algn="ctr">
+            <a:pPr algn="ctr" marL="0" indent="0">
+              <a:buNone/>
               <a:defRPr sz="2775" b="1">
                 <a:solidFill>
                   <a:srgbClr val="47171C"/>
@@ -5586,7 +5657,8 @@
           </a:bodyPr>
           <a:lstStyle/>
           <a:p>
-            <a:pPr algn="ctr">
+            <a:pPr algn="ctr" marL="0" indent="0">
+              <a:buNone/>
               <a:defRPr sz="2100" b="0">
                 <a:solidFill>
                   <a:srgbClr val="423C3B"/>
@@ -5609,7 +5681,8 @@
             </a:r>
           </a:p>
           <a:p>
-            <a:pPr algn="ctr">
+            <a:pPr algn="ctr" marL="0" indent="0">
+              <a:buNone/>
               <a:defRPr sz="2100" b="0">
                 <a:solidFill>
                   <a:srgbClr val="423C3B"/>
@@ -5760,7 +5833,8 @@
           </a:bodyPr>
           <a:lstStyle/>
           <a:p>
-            <a:pPr algn="ctr">
+            <a:pPr algn="ctr" marL="0" indent="0">
+              <a:buNone/>
               <a:defRPr sz="2700" b="1">
                 <a:solidFill>
                   <a:srgbClr val="FCF8F5"/>
@@ -5819,7 +5893,8 @@
           </a:bodyPr>
           <a:lstStyle/>
           <a:p>
-            <a:pPr algn="ctr">
+            <a:pPr algn="ctr" marL="0" indent="0">
+              <a:buNone/>
               <a:defRPr sz="2775" b="1">
                 <a:solidFill>
                   <a:srgbClr val="47171C"/>
@@ -5908,7 +5983,8 @@
           </a:bodyPr>
           <a:lstStyle/>
           <a:p>
-            <a:pPr algn="ctr">
+            <a:pPr algn="ctr" marL="0" indent="0">
+              <a:buNone/>
               <a:defRPr sz="2100" b="0">
                 <a:solidFill>
                   <a:srgbClr val="423C3B"/>
@@ -5931,7 +6007,8 @@
             </a:r>
           </a:p>
           <a:p>
-            <a:pPr algn="ctr">
+            <a:pPr algn="ctr" marL="0" indent="0">
+              <a:buNone/>
               <a:defRPr sz="2100" b="0">
                 <a:solidFill>
                   <a:srgbClr val="423C3B"/>
@@ -6082,7 +6159,8 @@
           </a:bodyPr>
           <a:lstStyle/>
           <a:p>
-            <a:pPr algn="ctr">
+            <a:pPr algn="ctr" marL="0" indent="0">
+              <a:buNone/>
               <a:defRPr sz="2700" b="1">
                 <a:solidFill>
                   <a:srgbClr val="FCF8F5"/>
@@ -6141,7 +6219,8 @@
           </a:bodyPr>
           <a:lstStyle/>
           <a:p>
-            <a:pPr algn="ctr">
+            <a:pPr algn="ctr" marL="0" indent="0">
+              <a:buNone/>
               <a:defRPr sz="2775" b="1">
                 <a:solidFill>
                   <a:srgbClr val="47171C"/>
@@ -6230,7 +6309,8 @@
           </a:bodyPr>
           <a:lstStyle/>
           <a:p>
-            <a:pPr algn="ctr">
+            <a:pPr algn="ctr" marL="0" indent="0">
+              <a:buNone/>
               <a:defRPr sz="2100" b="0">
                 <a:solidFill>
                   <a:srgbClr val="423C3B"/>
@@ -6253,7 +6333,8 @@
             </a:r>
           </a:p>
           <a:p>
-            <a:pPr algn="ctr">
+            <a:pPr algn="ctr" marL="0" indent="0">
+              <a:buNone/>
               <a:defRPr sz="2100" b="0">
                 <a:solidFill>
                   <a:srgbClr val="423C3B"/>
@@ -6492,7 +6573,8 @@
           </a:bodyPr>
           <a:lstStyle/>
           <a:p>
-            <a:pPr algn="ctr">
+            <a:pPr algn="ctr" marL="0" indent="0">
+              <a:buNone/>
               <a:defRPr sz="5250" b="1">
                 <a:solidFill>
                   <a:srgbClr val="47171C"/>
@@ -6551,7 +6633,8 @@
           </a:bodyPr>
           <a:lstStyle/>
           <a:p>
-            <a:pPr algn="ctr">
+            <a:pPr algn="ctr" marL="0" indent="0">
+              <a:buNone/>
               <a:defRPr sz="2175" b="0">
                 <a:solidFill>
                   <a:srgbClr val="423C3B"/>
@@ -6702,7 +6785,8 @@
           </a:bodyPr>
           <a:lstStyle/>
           <a:p>
-            <a:pPr algn="ctr">
+            <a:pPr algn="ctr" marL="0" indent="0">
+              <a:buNone/>
               <a:defRPr sz="2850" b="1">
                 <a:solidFill>
                   <a:srgbClr val="47171C"/>
@@ -6791,7 +6875,8 @@
           </a:bodyPr>
           <a:lstStyle/>
           <a:p>
-            <a:pPr algn="ctr">
+            <a:pPr algn="ctr" marL="0" indent="0">
+              <a:buNone/>
               <a:defRPr sz="2325" b="0">
                 <a:solidFill>
                   <a:srgbClr val="423C3B"/>
@@ -6814,12 +6899,16 @@
             </a:r>
           </a:p>
           <a:p>
+            <a:pPr marL="0" indent="0">
+              <a:buNone/>
+            </a:pPr>
             <a:r>
               <a:t/>
             </a:r>
           </a:p>
           <a:p>
-            <a:pPr algn="ctr">
+            <a:pPr algn="ctr" marL="0" indent="0">
+              <a:buNone/>
               <a:defRPr sz="2325" b="0">
                 <a:solidFill>
                   <a:srgbClr val="423C3B"/>
@@ -6842,12 +6931,16 @@
             </a:r>
           </a:p>
           <a:p>
+            <a:pPr marL="0" indent="0">
+              <a:buNone/>
+            </a:pPr>
             <a:r>
               <a:t/>
             </a:r>
           </a:p>
           <a:p>
-            <a:pPr algn="ctr">
+            <a:pPr algn="ctr" marL="0" indent="0">
+              <a:buNone/>
               <a:defRPr sz="2325" b="0">
                 <a:solidFill>
                   <a:srgbClr val="423C3B"/>
@@ -6938,7 +7031,8 @@
           </a:bodyPr>
           <a:lstStyle/>
           <a:p>
-            <a:pPr algn="ctr">
+            <a:pPr algn="ctr" marL="0" indent="0">
+              <a:buNone/>
               <a:defRPr sz="2850" b="1">
                 <a:solidFill>
                   <a:srgbClr val="47171C"/>
@@ -7027,7 +7121,8 @@
           </a:bodyPr>
           <a:lstStyle/>
           <a:p>
-            <a:pPr algn="ctr">
+            <a:pPr algn="ctr" marL="0" indent="0">
+              <a:buNone/>
               <a:defRPr sz="2325" b="0">
                 <a:solidFill>
                   <a:srgbClr val="423C3B"/>
@@ -7050,12 +7145,16 @@
             </a:r>
           </a:p>
           <a:p>
+            <a:pPr marL="0" indent="0">
+              <a:buNone/>
+            </a:pPr>
             <a:r>
               <a:t/>
             </a:r>
           </a:p>
           <a:p>
-            <a:pPr algn="ctr">
+            <a:pPr algn="ctr" marL="0" indent="0">
+              <a:buNone/>
               <a:defRPr sz="2325" b="0">
                 <a:solidFill>
                   <a:srgbClr val="423C3B"/>
@@ -7146,7 +7245,8 @@
           </a:bodyPr>
           <a:lstStyle/>
           <a:p>
-            <a:pPr algn="ctr">
+            <a:pPr algn="ctr" marL="0" indent="0">
+              <a:buNone/>
               <a:defRPr sz="2850" b="1">
                 <a:solidFill>
                   <a:srgbClr val="47171C"/>
@@ -7235,7 +7335,8 @@
           </a:bodyPr>
           <a:lstStyle/>
           <a:p>
-            <a:pPr algn="ctr">
+            <a:pPr algn="ctr" marL="0" indent="0">
+              <a:buNone/>
               <a:defRPr sz="2325" b="0">
                 <a:solidFill>
                   <a:srgbClr val="423C3B"/>
@@ -7258,12 +7359,16 @@
             </a:r>
           </a:p>
           <a:p>
+            <a:pPr marL="0" indent="0">
+              <a:buNone/>
+            </a:pPr>
             <a:r>
               <a:t/>
             </a:r>
           </a:p>
           <a:p>
-            <a:pPr algn="ctr">
+            <a:pPr algn="ctr" marL="0" indent="0">
+              <a:buNone/>
               <a:defRPr sz="2325" b="0">
                 <a:solidFill>
                   <a:srgbClr val="423C3B"/>
@@ -7414,7 +7519,8 @@
           </a:bodyPr>
           <a:lstStyle/>
           <a:p>
-            <a:pPr algn="ctr">
+            <a:pPr algn="ctr" marL="0" indent="0">
+              <a:buNone/>
               <a:defRPr sz="1950" b="0">
                 <a:solidFill>
                   <a:srgbClr val="47171C"/>
@@ -7593,7 +7699,8 @@
           </a:bodyPr>
           <a:lstStyle/>
           <a:p>
-            <a:pPr algn="ctr">
+            <a:pPr algn="ctr" marL="0" indent="0">
+              <a:buNone/>
               <a:defRPr sz="5250" b="1">
                 <a:solidFill>
                   <a:srgbClr val="47171C"/>
@@ -7652,7 +7759,8 @@
           </a:bodyPr>
           <a:lstStyle/>
           <a:p>
-            <a:pPr algn="ctr">
+            <a:pPr algn="ctr" marL="0" indent="0">
+              <a:buNone/>
               <a:defRPr sz="2175" b="0">
                 <a:solidFill>
                   <a:srgbClr val="423C3B"/>
@@ -7833,7 +7941,8 @@
           </a:bodyPr>
           <a:lstStyle/>
           <a:p>
-            <a:pPr algn="ctr">
+            <a:pPr algn="ctr" marL="0" indent="0">
+              <a:buNone/>
               <a:defRPr sz="2700" b="1">
                 <a:solidFill>
                   <a:srgbClr val="FCF8F5"/>
@@ -7892,7 +8001,8 @@
           </a:bodyPr>
           <a:lstStyle/>
           <a:p>
-            <a:pPr algn="ctr">
+            <a:pPr algn="ctr" marL="0" indent="0">
+              <a:buNone/>
               <a:defRPr sz="3225" b="1">
                 <a:solidFill>
                   <a:srgbClr val="47171C"/>
@@ -7981,7 +8091,8 @@
           </a:bodyPr>
           <a:lstStyle/>
           <a:p>
-            <a:pPr algn="ctr">
+            <a:pPr algn="ctr" marL="0" indent="0">
+              <a:buNone/>
               <a:defRPr sz="2100" b="0">
                 <a:solidFill>
                   <a:srgbClr val="423C3B"/>
@@ -8040,7 +8151,8 @@
           </a:bodyPr>
           <a:lstStyle/>
           <a:p>
-            <a:pPr algn="ctr">
+            <a:pPr algn="ctr" marL="0" indent="0">
+              <a:buNone/>
               <a:defRPr sz="4950" b="1">
                 <a:solidFill>
                   <a:srgbClr val="47171C"/>
@@ -8099,7 +8211,8 @@
           </a:bodyPr>
           <a:lstStyle/>
           <a:p>
-            <a:pPr algn="ctr">
+            <a:pPr algn="ctr" marL="0" indent="0">
+              <a:buNone/>
               <a:defRPr sz="2100" b="0">
                 <a:solidFill>
                   <a:srgbClr val="423C3B"/>
@@ -8220,7 +8333,8 @@
           </a:bodyPr>
           <a:lstStyle/>
           <a:p>
-            <a:pPr algn="ctr">
+            <a:pPr algn="ctr" marL="0" indent="0">
+              <a:buNone/>
               <a:defRPr sz="2700" b="1">
                 <a:solidFill>
                   <a:srgbClr val="FCF8F5"/>
@@ -8279,7 +8393,8 @@
           </a:bodyPr>
           <a:lstStyle/>
           <a:p>
-            <a:pPr algn="ctr">
+            <a:pPr algn="ctr" marL="0" indent="0">
+              <a:buNone/>
               <a:defRPr sz="3225" b="1">
                 <a:solidFill>
                   <a:srgbClr val="47171C"/>
@@ -8368,7 +8483,8 @@
           </a:bodyPr>
           <a:lstStyle/>
           <a:p>
-            <a:pPr algn="ctr">
+            <a:pPr algn="ctr" marL="0" indent="0">
+              <a:buNone/>
               <a:defRPr sz="2100" b="0">
                 <a:solidFill>
                   <a:srgbClr val="423C3B"/>
@@ -8427,7 +8543,8 @@
           </a:bodyPr>
           <a:lstStyle/>
           <a:p>
-            <a:pPr algn="ctr">
+            <a:pPr algn="ctr" marL="0" indent="0">
+              <a:buNone/>
               <a:defRPr sz="4950" b="1">
                 <a:solidFill>
                   <a:srgbClr val="47171C"/>
@@ -8486,7 +8603,8 @@
           </a:bodyPr>
           <a:lstStyle/>
           <a:p>
-            <a:pPr algn="ctr">
+            <a:pPr algn="ctr" marL="0" indent="0">
+              <a:buNone/>
               <a:defRPr sz="2100" b="0">
                 <a:solidFill>
                   <a:srgbClr val="423C3B"/>
@@ -8607,7 +8725,8 @@
           </a:bodyPr>
           <a:lstStyle/>
           <a:p>
-            <a:pPr algn="ctr">
+            <a:pPr algn="ctr" marL="0" indent="0">
+              <a:buNone/>
               <a:defRPr sz="2700" b="1">
                 <a:solidFill>
                   <a:srgbClr val="FCF8F5"/>
@@ -8666,7 +8785,8 @@
           </a:bodyPr>
           <a:lstStyle/>
           <a:p>
-            <a:pPr algn="ctr">
+            <a:pPr algn="ctr" marL="0" indent="0">
+              <a:buNone/>
               <a:defRPr sz="3225" b="1">
                 <a:solidFill>
                   <a:srgbClr val="47171C"/>
@@ -8755,7 +8875,8 @@
           </a:bodyPr>
           <a:lstStyle/>
           <a:p>
-            <a:pPr algn="ctr">
+            <a:pPr algn="ctr" marL="0" indent="0">
+              <a:buNone/>
               <a:defRPr sz="2100" b="0">
                 <a:solidFill>
                   <a:srgbClr val="423C3B"/>
@@ -8814,7 +8935,8 @@
           </a:bodyPr>
           <a:lstStyle/>
           <a:p>
-            <a:pPr algn="ctr">
+            <a:pPr algn="ctr" marL="0" indent="0">
+              <a:buNone/>
               <a:defRPr sz="4950" b="1">
                 <a:solidFill>
                   <a:srgbClr val="47171C"/>
@@ -8873,7 +8995,8 @@
           </a:bodyPr>
           <a:lstStyle/>
           <a:p>
-            <a:pPr algn="ctr">
+            <a:pPr algn="ctr" marL="0" indent="0">
+              <a:buNone/>
               <a:defRPr sz="2100" b="0">
                 <a:solidFill>
                   <a:srgbClr val="423C3B"/>
@@ -8964,7 +9087,8 @@
           </a:bodyPr>
           <a:lstStyle/>
           <a:p>
-            <a:pPr algn="ctr">
+            <a:pPr algn="ctr" marL="0" indent="0">
+              <a:buNone/>
               <a:defRPr sz="2775" b="1">
                 <a:solidFill>
                   <a:srgbClr val="47171C"/>
@@ -9023,7 +9147,8 @@
           </a:bodyPr>
           <a:lstStyle/>
           <a:p>
-            <a:pPr algn="ctr">
+            <a:pPr algn="ctr" marL="0" indent="0">
+              <a:buNone/>
               <a:defRPr sz="1950" b="0">
                 <a:solidFill>
                   <a:srgbClr val="423C3B"/>
@@ -9202,7 +9327,8 @@
           </a:bodyPr>
           <a:lstStyle/>
           <a:p>
-            <a:pPr algn="ctr">
+            <a:pPr algn="ctr" marL="0" indent="0">
+              <a:buNone/>
               <a:defRPr sz="5250" b="1">
                 <a:solidFill>
                   <a:srgbClr val="47171C"/>
@@ -9261,7 +9387,8 @@
           </a:bodyPr>
           <a:lstStyle/>
           <a:p>
-            <a:pPr algn="ctr">
+            <a:pPr algn="ctr" marL="0" indent="0">
+              <a:buNone/>
               <a:defRPr sz="2175" b="0">
                 <a:solidFill>
                   <a:srgbClr val="423C3B"/>
@@ -9444,7 +9571,8 @@
           </a:bodyPr>
           <a:lstStyle/>
           <a:p>
-            <a:pPr algn="ctr">
+            <a:pPr algn="ctr" marL="0" indent="0">
+              <a:buNone/>
               <a:defRPr sz="3225" b="1">
                 <a:solidFill>
                   <a:srgbClr val="47171C"/>
@@ -9503,7 +9631,8 @@
           </a:bodyPr>
           <a:lstStyle/>
           <a:p>
-            <a:pPr algn="ctr">
+            <a:pPr algn="ctr" marL="0" indent="0">
+              <a:buNone/>
               <a:defRPr sz="3225" b="1">
                 <a:solidFill>
                   <a:srgbClr val="47171C"/>
@@ -9622,7 +9751,8 @@
           </a:bodyPr>
           <a:lstStyle/>
           <a:p>
-            <a:pPr algn="l">
+            <a:pPr algn="l" marL="0" indent="0">
+              <a:buNone/>
               <a:defRPr sz="2400" b="0">
                 <a:solidFill>
                   <a:srgbClr val="423C3B"/>
@@ -9645,12 +9775,16 @@
             </a:r>
           </a:p>
           <a:p>
+            <a:pPr marL="0" indent="0">
+              <a:buNone/>
+            </a:pPr>
             <a:r>
               <a:t/>
             </a:r>
           </a:p>
           <a:p>
-            <a:pPr algn="l">
+            <a:pPr algn="l" marL="0" indent="0">
+              <a:buNone/>
               <a:defRPr sz="2400" b="0">
                 <a:solidFill>
                   <a:srgbClr val="423C3B"/>
@@ -9673,12 +9807,16 @@
             </a:r>
           </a:p>
           <a:p>
+            <a:pPr marL="0" indent="0">
+              <a:buNone/>
+            </a:pPr>
             <a:r>
               <a:t/>
             </a:r>
           </a:p>
           <a:p>
-            <a:pPr algn="l">
+            <a:pPr algn="l" marL="0" indent="0">
+              <a:buNone/>
               <a:defRPr sz="2400" b="0">
                 <a:solidFill>
                   <a:srgbClr val="423C3B"/>
@@ -9737,7 +9875,8 @@
           </a:bodyPr>
           <a:lstStyle/>
           <a:p>
-            <a:pPr algn="l">
+            <a:pPr algn="l" marL="0" indent="0">
+              <a:buNone/>
               <a:defRPr sz="2400" b="0">
                 <a:solidFill>
                   <a:srgbClr val="423C3B"/>
@@ -9760,12 +9899,16 @@
             </a:r>
           </a:p>
           <a:p>
+            <a:pPr marL="0" indent="0">
+              <a:buNone/>
+            </a:pPr>
             <a:r>
               <a:t/>
             </a:r>
           </a:p>
           <a:p>
-            <a:pPr algn="l">
+            <a:pPr algn="l" marL="0" indent="0">
+              <a:buNone/>
               <a:defRPr sz="2400" b="0">
                 <a:solidFill>
                   <a:srgbClr val="423C3B"/>
@@ -9788,12 +9931,16 @@
             </a:r>
           </a:p>
           <a:p>
+            <a:pPr marL="0" indent="0">
+              <a:buNone/>
+            </a:pPr>
             <a:r>
               <a:t/>
             </a:r>
           </a:p>
           <a:p>
-            <a:pPr algn="l">
+            <a:pPr algn="l" marL="0" indent="0">
+              <a:buNone/>
               <a:defRPr sz="2400" b="0">
                 <a:solidFill>
                   <a:srgbClr val="423C3B"/>
@@ -9884,7 +10031,8 @@
           </a:bodyPr>
           <a:lstStyle/>
           <a:p>
-            <a:pPr algn="ctr">
+            <a:pPr algn="ctr" marL="0" indent="0">
+              <a:buNone/>
               <a:defRPr sz="1950" b="0">
                 <a:solidFill>
                   <a:srgbClr val="47171C"/>
@@ -10063,7 +10211,8 @@
           </a:bodyPr>
           <a:lstStyle/>
           <a:p>
-            <a:pPr algn="ctr">
+            <a:pPr algn="ctr" marL="0" indent="0">
+              <a:buNone/>
               <a:defRPr sz="5250" b="1">
                 <a:solidFill>
                   <a:srgbClr val="47171C"/>
@@ -10122,7 +10271,8 @@
           </a:bodyPr>
           <a:lstStyle/>
           <a:p>
-            <a:pPr algn="ctr">
+            <a:pPr algn="ctr" marL="0" indent="0">
+              <a:buNone/>
               <a:defRPr sz="2175" b="0">
                 <a:solidFill>
                   <a:srgbClr val="423C3B"/>
@@ -10271,7 +10421,8 @@
           </a:bodyPr>
           <a:lstStyle/>
           <a:p>
-            <a:pPr algn="ctr">
+            <a:pPr algn="ctr" marL="0" indent="0">
+              <a:buNone/>
               <a:defRPr sz="2700" b="1">
                 <a:solidFill>
                   <a:srgbClr val="FCF8F5"/>
@@ -10330,7 +10481,8 @@
           </a:bodyPr>
           <a:lstStyle/>
           <a:p>
-            <a:pPr algn="l">
+            <a:pPr algn="l" marL="0" indent="0">
+              <a:buNone/>
               <a:defRPr sz="2700" b="1">
                 <a:solidFill>
                   <a:srgbClr val="47171C"/>
@@ -10389,7 +10541,8 @@
           </a:bodyPr>
           <a:lstStyle/>
           <a:p>
-            <a:pPr algn="l">
+            <a:pPr algn="l" marL="0" indent="0">
+              <a:buNone/>
               <a:defRPr sz="2250" b="0">
                 <a:solidFill>
                   <a:srgbClr val="423C3B"/>
@@ -10478,7 +10631,8 @@
           </a:bodyPr>
           <a:lstStyle/>
           <a:p>
-            <a:pPr algn="ctr">
+            <a:pPr algn="ctr" marL="0" indent="0">
+              <a:buNone/>
               <a:defRPr sz="2700" b="1">
                 <a:solidFill>
                   <a:srgbClr val="FCF8F5"/>
@@ -10537,7 +10691,8 @@
           </a:bodyPr>
           <a:lstStyle/>
           <a:p>
-            <a:pPr algn="l">
+            <a:pPr algn="l" marL="0" indent="0">
+              <a:buNone/>
               <a:defRPr sz="2700" b="1">
                 <a:solidFill>
                   <a:srgbClr val="47171C"/>
@@ -10596,7 +10751,8 @@
           </a:bodyPr>
           <a:lstStyle/>
           <a:p>
-            <a:pPr algn="l">
+            <a:pPr algn="l" marL="0" indent="0">
+              <a:buNone/>
               <a:defRPr sz="2250" b="0">
                 <a:solidFill>
                   <a:srgbClr val="423C3B"/>
@@ -10685,7 +10841,8 @@
           </a:bodyPr>
           <a:lstStyle/>
           <a:p>
-            <a:pPr algn="ctr">
+            <a:pPr algn="ctr" marL="0" indent="0">
+              <a:buNone/>
               <a:defRPr sz="2700" b="1">
                 <a:solidFill>
                   <a:srgbClr val="FCF8F5"/>
@@ -10744,7 +10901,8 @@
           </a:bodyPr>
           <a:lstStyle/>
           <a:p>
-            <a:pPr algn="l">
+            <a:pPr algn="l" marL="0" indent="0">
+              <a:buNone/>
               <a:defRPr sz="2700" b="1">
                 <a:solidFill>
                   <a:srgbClr val="47171C"/>
@@ -10803,7 +10961,8 @@
           </a:bodyPr>
           <a:lstStyle/>
           <a:p>
-            <a:pPr algn="l">
+            <a:pPr algn="l" marL="0" indent="0">
+              <a:buNone/>
               <a:defRPr sz="2250" b="0">
                 <a:solidFill>
                   <a:srgbClr val="423C3B"/>
@@ -10892,7 +11051,8 @@
           </a:bodyPr>
           <a:lstStyle/>
           <a:p>
-            <a:pPr algn="ctr">
+            <a:pPr algn="ctr" marL="0" indent="0">
+              <a:buNone/>
               <a:defRPr sz="2700" b="1">
                 <a:solidFill>
                   <a:srgbClr val="FCF8F5"/>
@@ -10951,7 +11111,8 @@
           </a:bodyPr>
           <a:lstStyle/>
           <a:p>
-            <a:pPr algn="l">
+            <a:pPr algn="l" marL="0" indent="0">
+              <a:buNone/>
               <a:defRPr sz="2700" b="1">
                 <a:solidFill>
                   <a:srgbClr val="47171C"/>
@@ -11010,7 +11171,8 @@
           </a:bodyPr>
           <a:lstStyle/>
           <a:p>
-            <a:pPr algn="l">
+            <a:pPr algn="l" marL="0" indent="0">
+              <a:buNone/>
               <a:defRPr sz="2250" b="0">
                 <a:solidFill>
                   <a:srgbClr val="423C3B"/>
@@ -11069,7 +11231,8 @@
           </a:bodyPr>
           <a:lstStyle/>
           <a:p>
-            <a:pPr algn="ctr">
+            <a:pPr algn="ctr" marL="0" indent="0">
+              <a:buNone/>
               <a:defRPr sz="2025" b="0">
                 <a:solidFill>
                   <a:srgbClr val="CF8792"/>
@@ -11715,7 +11878,8 @@
           </a:bodyPr>
           <a:lstStyle/>
           <a:p>
-            <a:pPr algn="ctr">
+            <a:pPr algn="ctr" marL="0" indent="0">
+              <a:buNone/>
               <a:defRPr sz="5250" b="1">
                 <a:solidFill>
                   <a:srgbClr val="47171C"/>
@@ -11774,7 +11938,8 @@
           </a:bodyPr>
           <a:lstStyle/>
           <a:p>
-            <a:pPr algn="ctr">
+            <a:pPr algn="ctr" marL="0" indent="0">
+              <a:buNone/>
               <a:defRPr sz="2175" b="0">
                 <a:solidFill>
                   <a:srgbClr val="423C3B"/>
@@ -11833,7 +11998,8 @@
           </a:bodyPr>
           <a:lstStyle/>
           <a:p>
-            <a:pPr algn="ctr">
+            <a:pPr algn="ctr" marL="0" indent="0">
+              <a:buNone/>
               <a:defRPr sz="4950" b="1">
                 <a:solidFill>
                   <a:srgbClr val="47171C"/>
@@ -11892,7 +12058,8 @@
           </a:bodyPr>
           <a:lstStyle/>
           <a:p>
-            <a:pPr algn="ctr">
+            <a:pPr algn="ctr" marL="0" indent="0">
+              <a:buNone/>
               <a:defRPr sz="2550" b="0">
                 <a:solidFill>
                   <a:srgbClr val="423C3B"/>
@@ -11951,7 +12118,8 @@
           </a:bodyPr>
           <a:lstStyle/>
           <a:p>
-            <a:pPr algn="ctr">
+            <a:pPr algn="ctr" marL="0" indent="0">
+              <a:buNone/>
               <a:defRPr sz="2250" b="0">
                 <a:solidFill>
                   <a:srgbClr val="CF8792"/>
@@ -12039,7 +12207,8 @@
           </a:bodyPr>
           <a:lstStyle/>
           <a:p>
-            <a:pPr algn="ctr">
+            <a:pPr algn="ctr" marL="0" indent="0">
+              <a:buNone/>
               <a:defRPr sz="5250" b="1">
                 <a:solidFill>
                   <a:srgbClr val="47171C"/>
@@ -12098,7 +12267,8 @@
           </a:bodyPr>
           <a:lstStyle/>
           <a:p>
-            <a:pPr algn="ctr">
+            <a:pPr algn="ctr" marL="0" indent="0">
+              <a:buNone/>
               <a:defRPr sz="2175" b="0">
                 <a:solidFill>
                   <a:srgbClr val="423C3B"/>
@@ -12157,7 +12327,8 @@
           </a:bodyPr>
           <a:lstStyle/>
           <a:p>
-            <a:pPr algn="ctr">
+            <a:pPr algn="ctr" marL="0" indent="0">
+              <a:buNone/>
               <a:defRPr sz="9900" b="1">
                 <a:solidFill>
                   <a:srgbClr val="CF8792"/>
@@ -12216,7 +12387,8 @@
           </a:bodyPr>
           <a:lstStyle/>
           <a:p>
-            <a:pPr algn="ctr">
+            <a:pPr algn="ctr" marL="0" indent="0">
+              <a:buNone/>
               <a:defRPr sz="3225" b="0">
                 <a:solidFill>
                   <a:srgbClr val="47171C"/>
@@ -12304,7 +12476,8 @@
           </a:bodyPr>
           <a:lstStyle/>
           <a:p>
-            <a:pPr algn="ctr">
+            <a:pPr algn="ctr" marL="0" indent="0">
+              <a:buNone/>
               <a:defRPr sz="5250" b="1">
                 <a:solidFill>
                   <a:srgbClr val="47171C"/>
@@ -12363,7 +12536,8 @@
           </a:bodyPr>
           <a:lstStyle/>
           <a:p>
-            <a:pPr algn="ctr">
+            <a:pPr algn="ctr" marL="0" indent="0">
+              <a:buNone/>
               <a:defRPr sz="2175" b="0">
                 <a:solidFill>
                   <a:srgbClr val="423C3B"/>
@@ -12422,7 +12596,8 @@
           </a:bodyPr>
           <a:lstStyle/>
           <a:p>
-            <a:pPr algn="ctr">
+            <a:pPr algn="ctr" marL="0" indent="0">
+              <a:buNone/>
               <a:defRPr sz="2700" b="1">
                 <a:solidFill>
                   <a:srgbClr val="FCF8F5"/>
@@ -12481,7 +12656,8 @@
           </a:bodyPr>
           <a:lstStyle/>
           <a:p>
-            <a:pPr algn="ctr">
+            <a:pPr algn="ctr" marL="0" indent="0">
+              <a:buNone/>
               <a:defRPr sz="3300" b="1">
                 <a:solidFill>
                   <a:srgbClr val="47171C"/>
@@ -12540,7 +12716,8 @@
           </a:bodyPr>
           <a:lstStyle/>
           <a:p>
-            <a:pPr algn="ctr">
+            <a:pPr algn="ctr" marL="0" indent="0">
+              <a:buNone/>
               <a:defRPr sz="1950" b="0">
                 <a:solidFill>
                   <a:srgbClr val="47171C"/>
@@ -12599,7 +12776,8 @@
           </a:bodyPr>
           <a:lstStyle/>
           <a:p>
-            <a:pPr algn="l">
+            <a:pPr algn="l" marL="0" indent="0">
+              <a:buNone/>
               <a:defRPr sz="2250" b="0">
                 <a:solidFill>
                   <a:srgbClr val="423C3B"/>
@@ -12622,12 +12800,16 @@
             </a:r>
           </a:p>
           <a:p>
+            <a:pPr marL="0" indent="0">
+              <a:buNone/>
+            </a:pPr>
             <a:r>
               <a:t/>
             </a:r>
           </a:p>
           <a:p>
-            <a:pPr algn="l">
+            <a:pPr algn="l" marL="0" indent="0">
+              <a:buNone/>
               <a:defRPr sz="2250" b="0">
                 <a:solidFill>
                   <a:srgbClr val="423C3B"/>
@@ -12650,12 +12832,16 @@
             </a:r>
           </a:p>
           <a:p>
+            <a:pPr marL="0" indent="0">
+              <a:buNone/>
+            </a:pPr>
             <a:r>
               <a:t/>
             </a:r>
           </a:p>
           <a:p>
-            <a:pPr algn="l">
+            <a:pPr algn="l" marL="0" indent="0">
+              <a:buNone/>
               <a:defRPr sz="2250" b="0">
                 <a:solidFill>
                   <a:srgbClr val="423C3B"/>
@@ -12714,7 +12900,8 @@
           </a:bodyPr>
           <a:lstStyle/>
           <a:p>
-            <a:pPr algn="ctr">
+            <a:pPr algn="ctr" marL="0" indent="0">
+              <a:buNone/>
               <a:defRPr sz="2700" b="1">
                 <a:solidFill>
                   <a:srgbClr val="FCF8F5"/>
@@ -12773,7 +12960,8 @@
           </a:bodyPr>
           <a:lstStyle/>
           <a:p>
-            <a:pPr algn="ctr">
+            <a:pPr algn="ctr" marL="0" indent="0">
+              <a:buNone/>
               <a:defRPr sz="3300" b="1">
                 <a:solidFill>
                   <a:srgbClr val="47171C"/>
@@ -12832,7 +13020,8 @@
           </a:bodyPr>
           <a:lstStyle/>
           <a:p>
-            <a:pPr algn="ctr">
+            <a:pPr algn="ctr" marL="0" indent="0">
+              <a:buNone/>
               <a:defRPr sz="1950" b="0">
                 <a:solidFill>
                   <a:srgbClr val="47171C"/>
@@ -12891,7 +13080,8 @@
           </a:bodyPr>
           <a:lstStyle/>
           <a:p>
-            <a:pPr algn="l">
+            <a:pPr algn="l" marL="0" indent="0">
+              <a:buNone/>
               <a:defRPr sz="2250" b="0">
                 <a:solidFill>
                   <a:srgbClr val="423C3B"/>
@@ -12914,12 +13104,16 @@
             </a:r>
           </a:p>
           <a:p>
+            <a:pPr marL="0" indent="0">
+              <a:buNone/>
+            </a:pPr>
             <a:r>
               <a:t/>
             </a:r>
           </a:p>
           <a:p>
-            <a:pPr algn="l">
+            <a:pPr algn="l" marL="0" indent="0">
+              <a:buNone/>
               <a:defRPr sz="2250" b="0">
                 <a:solidFill>
                   <a:srgbClr val="423C3B"/>
@@ -12942,12 +13136,16 @@
             </a:r>
           </a:p>
           <a:p>
+            <a:pPr marL="0" indent="0">
+              <a:buNone/>
+            </a:pPr>
             <a:r>
               <a:t/>
             </a:r>
           </a:p>
           <a:p>
-            <a:pPr algn="l">
+            <a:pPr algn="l" marL="0" indent="0">
+              <a:buNone/>
               <a:defRPr sz="2250" b="0">
                 <a:solidFill>
                   <a:srgbClr val="423C3B"/>
@@ -13006,7 +13204,8 @@
           </a:bodyPr>
           <a:lstStyle/>
           <a:p>
-            <a:pPr algn="ctr">
+            <a:pPr algn="ctr" marL="0" indent="0">
+              <a:buNone/>
               <a:defRPr sz="2700" b="1">
                 <a:solidFill>
                   <a:srgbClr val="FCF8F5"/>
@@ -13065,7 +13264,8 @@
           </a:bodyPr>
           <a:lstStyle/>
           <a:p>
-            <a:pPr algn="ctr">
+            <a:pPr algn="ctr" marL="0" indent="0">
+              <a:buNone/>
               <a:defRPr sz="3300" b="1">
                 <a:solidFill>
                   <a:srgbClr val="47171C"/>
@@ -13124,7 +13324,8 @@
           </a:bodyPr>
           <a:lstStyle/>
           <a:p>
-            <a:pPr algn="ctr">
+            <a:pPr algn="ctr" marL="0" indent="0">
+              <a:buNone/>
               <a:defRPr sz="1950" b="0">
                 <a:solidFill>
                   <a:srgbClr val="47171C"/>
@@ -13183,7 +13384,8 @@
           </a:bodyPr>
           <a:lstStyle/>
           <a:p>
-            <a:pPr algn="l">
+            <a:pPr algn="l" marL="0" indent="0">
+              <a:buNone/>
               <a:defRPr sz="2250" b="0">
                 <a:solidFill>
                   <a:srgbClr val="423C3B"/>
@@ -13206,12 +13408,16 @@
             </a:r>
           </a:p>
           <a:p>
+            <a:pPr marL="0" indent="0">
+              <a:buNone/>
+            </a:pPr>
             <a:r>
               <a:t/>
             </a:r>
           </a:p>
           <a:p>
-            <a:pPr algn="l">
+            <a:pPr algn="l" marL="0" indent="0">
+              <a:buNone/>
               <a:defRPr sz="2250" b="0">
                 <a:solidFill>
                   <a:srgbClr val="423C3B"/>
@@ -13234,12 +13440,16 @@
             </a:r>
           </a:p>
           <a:p>
+            <a:pPr marL="0" indent="0">
+              <a:buNone/>
+            </a:pPr>
             <a:r>
               <a:t/>
             </a:r>
           </a:p>
           <a:p>
-            <a:pPr algn="l">
+            <a:pPr algn="l" marL="0" indent="0">
+              <a:buNone/>
               <a:defRPr sz="2250" b="0">
                 <a:solidFill>
                   <a:srgbClr val="423C3B"/>
@@ -13327,7 +13537,8 @@
           </a:bodyPr>
           <a:lstStyle/>
           <a:p>
-            <a:pPr algn="ctr">
+            <a:pPr algn="ctr" marL="0" indent="0">
+              <a:buNone/>
               <a:defRPr sz="5250" b="1">
                 <a:solidFill>
                   <a:srgbClr val="47171C"/>
@@ -13386,7 +13597,8 @@
           </a:bodyPr>
           <a:lstStyle/>
           <a:p>
-            <a:pPr algn="ctr">
+            <a:pPr algn="ctr" marL="0" indent="0">
+              <a:buNone/>
               <a:defRPr sz="2175" b="0">
                 <a:solidFill>
                   <a:srgbClr val="423C3B"/>
@@ -13445,7 +13657,8 @@
           </a:bodyPr>
           <a:lstStyle/>
           <a:p>
-            <a:pPr algn="ctr">
+            <a:pPr algn="ctr" marL="0" indent="0">
+              <a:buNone/>
               <a:defRPr sz="2700" b="1">
                 <a:solidFill>
                   <a:srgbClr val="FCF8F5"/>
@@ -13504,7 +13717,8 @@
           </a:bodyPr>
           <a:lstStyle/>
           <a:p>
-            <a:pPr algn="ctr">
+            <a:pPr algn="ctr" marL="0" indent="0">
+              <a:buNone/>
               <a:defRPr sz="2775" b="1">
                 <a:solidFill>
                   <a:srgbClr val="47171C"/>
@@ -13563,7 +13777,8 @@
           </a:bodyPr>
           <a:lstStyle/>
           <a:p>
-            <a:pPr algn="ctr">
+            <a:pPr algn="ctr" marL="0" indent="0">
+              <a:buNone/>
               <a:defRPr sz="2100" b="0">
                 <a:solidFill>
                   <a:srgbClr val="423C3B"/>
@@ -13586,7 +13801,8 @@
             </a:r>
           </a:p>
           <a:p>
-            <a:pPr algn="ctr">
+            <a:pPr algn="ctr" marL="0" indent="0">
+              <a:buNone/>
               <a:defRPr sz="2100" b="0">
                 <a:solidFill>
                   <a:srgbClr val="423C3B"/>
@@ -13645,7 +13861,8 @@
           </a:bodyPr>
           <a:lstStyle/>
           <a:p>
-            <a:pPr algn="ctr">
+            <a:pPr algn="ctr" marL="0" indent="0">
+              <a:buNone/>
               <a:defRPr sz="2700" b="1">
                 <a:solidFill>
                   <a:srgbClr val="FCF8F5"/>
@@ -13704,7 +13921,8 @@
           </a:bodyPr>
           <a:lstStyle/>
           <a:p>
-            <a:pPr algn="ctr">
+            <a:pPr algn="ctr" marL="0" indent="0">
+              <a:buNone/>
               <a:defRPr sz="2775" b="1">
                 <a:solidFill>
                   <a:srgbClr val="47171C"/>
@@ -13763,7 +13981,8 @@
           </a:bodyPr>
           <a:lstStyle/>
           <a:p>
-            <a:pPr algn="ctr">
+            <a:pPr algn="ctr" marL="0" indent="0">
+              <a:buNone/>
               <a:defRPr sz="2100" b="0">
                 <a:solidFill>
                   <a:srgbClr val="423C3B"/>
@@ -13786,7 +14005,8 @@
             </a:r>
           </a:p>
           <a:p>
-            <a:pPr algn="ctr">
+            <a:pPr algn="ctr" marL="0" indent="0">
+              <a:buNone/>
               <a:defRPr sz="2100" b="0">
                 <a:solidFill>
                   <a:srgbClr val="423C3B"/>
@@ -13845,7 +14065,8 @@
           </a:bodyPr>
           <a:lstStyle/>
           <a:p>
-            <a:pPr algn="ctr">
+            <a:pPr algn="ctr" marL="0" indent="0">
+              <a:buNone/>
               <a:defRPr sz="2700" b="1">
                 <a:solidFill>
                   <a:srgbClr val="FCF8F5"/>
@@ -13904,7 +14125,8 @@
           </a:bodyPr>
           <a:lstStyle/>
           <a:p>
-            <a:pPr algn="ctr">
+            <a:pPr algn="ctr" marL="0" indent="0">
+              <a:buNone/>
               <a:defRPr sz="2775" b="1">
                 <a:solidFill>
                   <a:srgbClr val="47171C"/>
@@ -13963,7 +14185,8 @@
           </a:bodyPr>
           <a:lstStyle/>
           <a:p>
-            <a:pPr algn="ctr">
+            <a:pPr algn="ctr" marL="0" indent="0">
+              <a:buNone/>
               <a:defRPr sz="2100" b="0">
                 <a:solidFill>
                   <a:srgbClr val="423C3B"/>
@@ -13986,7 +14209,8 @@
             </a:r>
           </a:p>
           <a:p>
-            <a:pPr algn="ctr">
+            <a:pPr algn="ctr" marL="0" indent="0">
+              <a:buNone/>
               <a:defRPr sz="2100" b="0">
                 <a:solidFill>
                   <a:srgbClr val="423C3B"/>
@@ -14045,7 +14269,8 @@
           </a:bodyPr>
           <a:lstStyle/>
           <a:p>
-            <a:pPr algn="ctr">
+            <a:pPr algn="ctr" marL="0" indent="0">
+              <a:buNone/>
               <a:defRPr sz="2700" b="1">
                 <a:solidFill>
                   <a:srgbClr val="FCF8F5"/>
@@ -14104,7 +14329,8 @@
           </a:bodyPr>
           <a:lstStyle/>
           <a:p>
-            <a:pPr algn="ctr">
+            <a:pPr algn="ctr" marL="0" indent="0">
+              <a:buNone/>
               <a:defRPr sz="2775" b="1">
                 <a:solidFill>
                   <a:srgbClr val="47171C"/>
@@ -14163,7 +14389,8 @@
           </a:bodyPr>
           <a:lstStyle/>
           <a:p>
-            <a:pPr algn="ctr">
+            <a:pPr algn="ctr" marL="0" indent="0">
+              <a:buNone/>
               <a:defRPr sz="2100" b="0">
                 <a:solidFill>
                   <a:srgbClr val="423C3B"/>
@@ -14186,7 +14413,8 @@
             </a:r>
           </a:p>
           <a:p>
-            <a:pPr algn="ctr">
+            <a:pPr algn="ctr" marL="0" indent="0">
+              <a:buNone/>
               <a:defRPr sz="2100" b="0">
                 <a:solidFill>
                   <a:srgbClr val="423C3B"/>
@@ -14245,7 +14473,8 @@
           </a:bodyPr>
           <a:lstStyle/>
           <a:p>
-            <a:pPr algn="ctr">
+            <a:pPr algn="ctr" marL="0" indent="0">
+              <a:buNone/>
               <a:defRPr sz="2700" b="1">
                 <a:solidFill>
                   <a:srgbClr val="FCF8F5"/>
@@ -14304,7 +14533,8 @@
           </a:bodyPr>
           <a:lstStyle/>
           <a:p>
-            <a:pPr algn="ctr">
+            <a:pPr algn="ctr" marL="0" indent="0">
+              <a:buNone/>
               <a:defRPr sz="2775" b="1">
                 <a:solidFill>
                   <a:srgbClr val="47171C"/>
@@ -14363,7 +14593,8 @@
           </a:bodyPr>
           <a:lstStyle/>
           <a:p>
-            <a:pPr algn="ctr">
+            <a:pPr algn="ctr" marL="0" indent="0">
+              <a:buNone/>
               <a:defRPr sz="2100" b="0">
                 <a:solidFill>
                   <a:srgbClr val="423C3B"/>
@@ -14386,7 +14617,8 @@
             </a:r>
           </a:p>
           <a:p>
-            <a:pPr algn="ctr">
+            <a:pPr algn="ctr" marL="0" indent="0">
+              <a:buNone/>
               <a:defRPr sz="2100" b="0">
                 <a:solidFill>
                   <a:srgbClr val="423C3B"/>
@@ -14445,7 +14677,8 @@
           </a:bodyPr>
           <a:lstStyle/>
           <a:p>
-            <a:pPr algn="ctr">
+            <a:pPr algn="ctr" marL="0" indent="0">
+              <a:buNone/>
               <a:defRPr sz="2700" b="1">
                 <a:solidFill>
                   <a:srgbClr val="FCF8F5"/>
@@ -14504,7 +14737,8 @@
           </a:bodyPr>
           <a:lstStyle/>
           <a:p>
-            <a:pPr algn="ctr">
+            <a:pPr algn="ctr" marL="0" indent="0">
+              <a:buNone/>
               <a:defRPr sz="2775" b="1">
                 <a:solidFill>
                   <a:srgbClr val="47171C"/>
@@ -14563,7 +14797,8 @@
           </a:bodyPr>
           <a:lstStyle/>
           <a:p>
-            <a:pPr algn="ctr">
+            <a:pPr algn="ctr" marL="0" indent="0">
+              <a:buNone/>
               <a:defRPr sz="2100" b="0">
                 <a:solidFill>
                   <a:srgbClr val="423C3B"/>
@@ -14586,7 +14821,8 @@
             </a:r>
           </a:p>
           <a:p>
-            <a:pPr algn="ctr">
+            <a:pPr algn="ctr" marL="0" indent="0">
+              <a:buNone/>
               <a:defRPr sz="2100" b="0">
                 <a:solidFill>
                   <a:srgbClr val="423C3B"/>
@@ -14645,7 +14881,8 @@
           </a:bodyPr>
           <a:lstStyle/>
           <a:p>
-            <a:pPr algn="ctr">
+            <a:pPr algn="ctr" marL="0" indent="0">
+              <a:buNone/>
               <a:defRPr sz="2700" b="1">
                 <a:solidFill>
                   <a:srgbClr val="FCF8F5"/>
@@ -14704,7 +14941,8 @@
           </a:bodyPr>
           <a:lstStyle/>
           <a:p>
-            <a:pPr algn="ctr">
+            <a:pPr algn="ctr" marL="0" indent="0">
+              <a:buNone/>
               <a:defRPr sz="2775" b="1">
                 <a:solidFill>
                   <a:srgbClr val="47171C"/>
@@ -14763,7 +15001,8 @@
           </a:bodyPr>
           <a:lstStyle/>
           <a:p>
-            <a:pPr algn="ctr">
+            <a:pPr algn="ctr" marL="0" indent="0">
+              <a:buNone/>
               <a:defRPr sz="2100" b="0">
                 <a:solidFill>
                   <a:srgbClr val="423C3B"/>
@@ -14786,7 +15025,8 @@
             </a:r>
           </a:p>
           <a:p>
-            <a:pPr algn="ctr">
+            <a:pPr algn="ctr" marL="0" indent="0">
+              <a:buNone/>
               <a:defRPr sz="2100" b="0">
                 <a:solidFill>
                   <a:srgbClr val="423C3B"/>
@@ -14845,7 +15085,8 @@
           </a:bodyPr>
           <a:lstStyle/>
           <a:p>
-            <a:pPr algn="ctr">
+            <a:pPr algn="ctr" marL="0" indent="0">
+              <a:buNone/>
               <a:defRPr sz="2700" b="1">
                 <a:solidFill>
                   <a:srgbClr val="FCF8F5"/>
@@ -14904,7 +15145,8 @@
           </a:bodyPr>
           <a:lstStyle/>
           <a:p>
-            <a:pPr algn="ctr">
+            <a:pPr algn="ctr" marL="0" indent="0">
+              <a:buNone/>
               <a:defRPr sz="2775" b="1">
                 <a:solidFill>
                   <a:srgbClr val="47171C"/>
@@ -14963,7 +15205,8 @@
           </a:bodyPr>
           <a:lstStyle/>
           <a:p>
-            <a:pPr algn="ctr">
+            <a:pPr algn="ctr" marL="0" indent="0">
+              <a:buNone/>
               <a:defRPr sz="2100" b="0">
                 <a:solidFill>
                   <a:srgbClr val="423C3B"/>
@@ -14986,7 +15229,8 @@
             </a:r>
           </a:p>
           <a:p>
-            <a:pPr algn="ctr">
+            <a:pPr algn="ctr" marL="0" indent="0">
+              <a:buNone/>
               <a:defRPr sz="2100" b="0">
                 <a:solidFill>
                   <a:srgbClr val="423C3B"/>
@@ -15074,7 +15318,8 @@
           </a:bodyPr>
           <a:lstStyle/>
           <a:p>
-            <a:pPr algn="ctr">
+            <a:pPr algn="ctr" marL="0" indent="0">
+              <a:buNone/>
               <a:defRPr sz="5250" b="1">
                 <a:solidFill>
                   <a:srgbClr val="47171C"/>
@@ -15133,7 +15378,8 @@
           </a:bodyPr>
           <a:lstStyle/>
           <a:p>
-            <a:pPr algn="ctr">
+            <a:pPr algn="ctr" marL="0" indent="0">
+              <a:buNone/>
               <a:defRPr sz="2175" b="0">
                 <a:solidFill>
                   <a:srgbClr val="423C3B"/>
@@ -15192,7 +15438,8 @@
           </a:bodyPr>
           <a:lstStyle/>
           <a:p>
-            <a:pPr algn="ctr">
+            <a:pPr algn="ctr" marL="0" indent="0">
+              <a:buNone/>
               <a:defRPr sz="2850" b="1">
                 <a:solidFill>
                   <a:srgbClr val="47171C"/>
@@ -15251,7 +15498,8 @@
           </a:bodyPr>
           <a:lstStyle/>
           <a:p>
-            <a:pPr algn="ctr">
+            <a:pPr algn="ctr" marL="0" indent="0">
+              <a:buNone/>
               <a:defRPr sz="2325" b="0">
                 <a:solidFill>
                   <a:srgbClr val="423C3B"/>
@@ -15274,12 +15522,16 @@
             </a:r>
           </a:p>
           <a:p>
+            <a:pPr marL="0" indent="0">
+              <a:buNone/>
+            </a:pPr>
             <a:r>
               <a:t/>
             </a:r>
           </a:p>
           <a:p>
-            <a:pPr algn="ctr">
+            <a:pPr algn="ctr" marL="0" indent="0">
+              <a:buNone/>
               <a:defRPr sz="2325" b="0">
                 <a:solidFill>
                   <a:srgbClr val="423C3B"/>
@@ -15302,12 +15554,16 @@
             </a:r>
           </a:p>
           <a:p>
+            <a:pPr marL="0" indent="0">
+              <a:buNone/>
+            </a:pPr>
             <a:r>
               <a:t/>
             </a:r>
           </a:p>
           <a:p>
-            <a:pPr algn="ctr">
+            <a:pPr algn="ctr" marL="0" indent="0">
+              <a:buNone/>
               <a:defRPr sz="2325" b="0">
                 <a:solidFill>
                   <a:srgbClr val="423C3B"/>
@@ -15366,7 +15622,8 @@
           </a:bodyPr>
           <a:lstStyle/>
           <a:p>
-            <a:pPr algn="ctr">
+            <a:pPr algn="ctr" marL="0" indent="0">
+              <a:buNone/>
               <a:defRPr sz="2850" b="1">
                 <a:solidFill>
                   <a:srgbClr val="47171C"/>
@@ -15425,7 +15682,8 @@
           </a:bodyPr>
           <a:lstStyle/>
           <a:p>
-            <a:pPr algn="ctr">
+            <a:pPr algn="ctr" marL="0" indent="0">
+              <a:buNone/>
               <a:defRPr sz="2325" b="0">
                 <a:solidFill>
                   <a:srgbClr val="423C3B"/>
@@ -15448,12 +15706,16 @@
             </a:r>
           </a:p>
           <a:p>
+            <a:pPr marL="0" indent="0">
+              <a:buNone/>
+            </a:pPr>
             <a:r>
               <a:t/>
             </a:r>
           </a:p>
           <a:p>
-            <a:pPr algn="ctr">
+            <a:pPr algn="ctr" marL="0" indent="0">
+              <a:buNone/>
               <a:defRPr sz="2325" b="0">
                 <a:solidFill>
                   <a:srgbClr val="423C3B"/>
@@ -15512,7 +15774,8 @@
           </a:bodyPr>
           <a:lstStyle/>
           <a:p>
-            <a:pPr algn="ctr">
+            <a:pPr algn="ctr" marL="0" indent="0">
+              <a:buNone/>
               <a:defRPr sz="2850" b="1">
                 <a:solidFill>
                   <a:srgbClr val="47171C"/>
@@ -15571,7 +15834,8 @@
           </a:bodyPr>
           <a:lstStyle/>
           <a:p>
-            <a:pPr algn="ctr">
+            <a:pPr algn="ctr" marL="0" indent="0">
+              <a:buNone/>
               <a:defRPr sz="2325" b="0">
                 <a:solidFill>
                   <a:srgbClr val="423C3B"/>
@@ -15594,12 +15858,16 @@
             </a:r>
           </a:p>
           <a:p>
+            <a:pPr marL="0" indent="0">
+              <a:buNone/>
+            </a:pPr>
             <a:r>
               <a:t/>
             </a:r>
           </a:p>
           <a:p>
-            <a:pPr algn="ctr">
+            <a:pPr algn="ctr" marL="0" indent="0">
+              <a:buNone/>
               <a:defRPr sz="2325" b="0">
                 <a:solidFill>
                   <a:srgbClr val="423C3B"/>
@@ -15658,7 +15926,8 @@
           </a:bodyPr>
           <a:lstStyle/>
           <a:p>
-            <a:pPr algn="ctr">
+            <a:pPr algn="ctr" marL="0" indent="0">
+              <a:buNone/>
               <a:defRPr sz="1950" b="0">
                 <a:solidFill>
                   <a:srgbClr val="47171C"/>
@@ -15746,7 +16015,8 @@
           </a:bodyPr>
           <a:lstStyle/>
           <a:p>
-            <a:pPr algn="ctr">
+            <a:pPr algn="ctr" marL="0" indent="0">
+              <a:buNone/>
               <a:defRPr sz="5250" b="1">
                 <a:solidFill>
                   <a:srgbClr val="47171C"/>
@@ -15805,7 +16075,8 @@
           </a:bodyPr>
           <a:lstStyle/>
           <a:p>
-            <a:pPr algn="ctr">
+            <a:pPr algn="ctr" marL="0" indent="0">
+              <a:buNone/>
               <a:defRPr sz="2175" b="0">
                 <a:solidFill>
                   <a:srgbClr val="423C3B"/>
@@ -15864,7 +16135,8 @@
           </a:bodyPr>
           <a:lstStyle/>
           <a:p>
-            <a:pPr algn="ctr">
+            <a:pPr algn="ctr" marL="0" indent="0">
+              <a:buNone/>
               <a:defRPr sz="2700" b="1">
                 <a:solidFill>
                   <a:srgbClr val="FCF8F5"/>
@@ -15923,7 +16195,8 @@
           </a:bodyPr>
           <a:lstStyle/>
           <a:p>
-            <a:pPr algn="ctr">
+            <a:pPr algn="ctr" marL="0" indent="0">
+              <a:buNone/>
               <a:defRPr sz="3225" b="1">
                 <a:solidFill>
                   <a:srgbClr val="47171C"/>
@@ -15982,7 +16255,8 @@
           </a:bodyPr>
           <a:lstStyle/>
           <a:p>
-            <a:pPr algn="ctr">
+            <a:pPr algn="ctr" marL="0" indent="0">
+              <a:buNone/>
               <a:defRPr sz="2100" b="0">
                 <a:solidFill>
                   <a:srgbClr val="423C3B"/>
@@ -16041,7 +16315,8 @@
           </a:bodyPr>
           <a:lstStyle/>
           <a:p>
-            <a:pPr algn="ctr">
+            <a:pPr algn="ctr" marL="0" indent="0">
+              <a:buNone/>
               <a:defRPr sz="4950" b="1">
                 <a:solidFill>
                   <a:srgbClr val="47171C"/>
@@ -16100,7 +16375,8 @@
           </a:bodyPr>
           <a:lstStyle/>
           <a:p>
-            <a:pPr algn="ctr">
+            <a:pPr algn="ctr" marL="0" indent="0">
+              <a:buNone/>
               <a:defRPr sz="2100" b="0">
                 <a:solidFill>
                   <a:srgbClr val="423C3B"/>
@@ -16159,7 +16435,8 @@
           </a:bodyPr>
           <a:lstStyle/>
           <a:p>
-            <a:pPr algn="ctr">
+            <a:pPr algn="ctr" marL="0" indent="0">
+              <a:buNone/>
               <a:defRPr sz="2700" b="1">
                 <a:solidFill>
                   <a:srgbClr val="FCF8F5"/>
@@ -16218,7 +16495,8 @@
           </a:bodyPr>
           <a:lstStyle/>
           <a:p>
-            <a:pPr algn="ctr">
+            <a:pPr algn="ctr" marL="0" indent="0">
+              <a:buNone/>
               <a:defRPr sz="3225" b="1">
                 <a:solidFill>
                   <a:srgbClr val="47171C"/>
@@ -16277,7 +16555,8 @@
           </a:bodyPr>
           <a:lstStyle/>
           <a:p>
-            <a:pPr algn="ctr">
+            <a:pPr algn="ctr" marL="0" indent="0">
+              <a:buNone/>
               <a:defRPr sz="2100" b="0">
                 <a:solidFill>
                   <a:srgbClr val="423C3B"/>
@@ -16336,7 +16615,8 @@
           </a:bodyPr>
           <a:lstStyle/>
           <a:p>
-            <a:pPr algn="ctr">
+            <a:pPr algn="ctr" marL="0" indent="0">
+              <a:buNone/>
               <a:defRPr sz="4950" b="1">
                 <a:solidFill>
                   <a:srgbClr val="47171C"/>
@@ -16395,7 +16675,8 @@
           </a:bodyPr>
           <a:lstStyle/>
           <a:p>
-            <a:pPr algn="ctr">
+            <a:pPr algn="ctr" marL="0" indent="0">
+              <a:buNone/>
               <a:defRPr sz="2100" b="0">
                 <a:solidFill>
                   <a:srgbClr val="423C3B"/>
@@ -16454,7 +16735,8 @@
           </a:bodyPr>
           <a:lstStyle/>
           <a:p>
-            <a:pPr algn="ctr">
+            <a:pPr algn="ctr" marL="0" indent="0">
+              <a:buNone/>
               <a:defRPr sz="2700" b="1">
                 <a:solidFill>
                   <a:srgbClr val="FCF8F5"/>
@@ -16513,7 +16795,8 @@
           </a:bodyPr>
           <a:lstStyle/>
           <a:p>
-            <a:pPr algn="ctr">
+            <a:pPr algn="ctr" marL="0" indent="0">
+              <a:buNone/>
               <a:defRPr sz="3225" b="1">
                 <a:solidFill>
                   <a:srgbClr val="47171C"/>
@@ -16572,7 +16855,8 @@
           </a:bodyPr>
           <a:lstStyle/>
           <a:p>
-            <a:pPr algn="ctr">
+            <a:pPr algn="ctr" marL="0" indent="0">
+              <a:buNone/>
               <a:defRPr sz="2100" b="0">
                 <a:solidFill>
                   <a:srgbClr val="423C3B"/>
@@ -16631,7 +16915,8 @@
           </a:bodyPr>
           <a:lstStyle/>
           <a:p>
-            <a:pPr algn="ctr">
+            <a:pPr algn="ctr" marL="0" indent="0">
+              <a:buNone/>
               <a:defRPr sz="4950" b="1">
                 <a:solidFill>
                   <a:srgbClr val="47171C"/>
@@ -16690,7 +16975,8 @@
           </a:bodyPr>
           <a:lstStyle/>
           <a:p>
-            <a:pPr algn="ctr">
+            <a:pPr algn="ctr" marL="0" indent="0">
+              <a:buNone/>
               <a:defRPr sz="2100" b="0">
                 <a:solidFill>
                   <a:srgbClr val="423C3B"/>
@@ -16749,7 +17035,8 @@
           </a:bodyPr>
           <a:lstStyle/>
           <a:p>
-            <a:pPr algn="ctr">
+            <a:pPr algn="ctr" marL="0" indent="0">
+              <a:buNone/>
               <a:defRPr sz="2775" b="1">
                 <a:solidFill>
                   <a:srgbClr val="47171C"/>
@@ -16808,7 +17095,8 @@
           </a:bodyPr>
           <a:lstStyle/>
           <a:p>
-            <a:pPr algn="ctr">
+            <a:pPr algn="ctr" marL="0" indent="0">
+              <a:buNone/>
               <a:defRPr sz="1950" b="0">
                 <a:solidFill>
                   <a:srgbClr val="423C3B"/>
@@ -16896,7 +17184,8 @@
           </a:bodyPr>
           <a:lstStyle/>
           <a:p>
-            <a:pPr algn="ctr">
+            <a:pPr algn="ctr" marL="0" indent="0">
+              <a:buNone/>
               <a:defRPr sz="5250" b="1">
                 <a:solidFill>
                   <a:srgbClr val="47171C"/>
@@ -16955,7 +17244,8 @@
           </a:bodyPr>
           <a:lstStyle/>
           <a:p>
-            <a:pPr algn="ctr">
+            <a:pPr algn="ctr" marL="0" indent="0">
+              <a:buNone/>
               <a:defRPr sz="2175" b="0">
                 <a:solidFill>
                   <a:srgbClr val="423C3B"/>
@@ -17014,7 +17304,8 @@
           </a:bodyPr>
           <a:lstStyle/>
           <a:p>
-            <a:pPr algn="ctr">
+            <a:pPr algn="ctr" marL="0" indent="0">
+              <a:buNone/>
               <a:defRPr sz="3225" b="1">
                 <a:solidFill>
                   <a:srgbClr val="47171C"/>
@@ -17073,7 +17364,8 @@
           </a:bodyPr>
           <a:lstStyle/>
           <a:p>
-            <a:pPr algn="ctr">
+            <a:pPr algn="ctr" marL="0" indent="0">
+              <a:buNone/>
               <a:defRPr sz="3225" b="1">
                 <a:solidFill>
                   <a:srgbClr val="47171C"/>
@@ -17132,7 +17424,8 @@
           </a:bodyPr>
           <a:lstStyle/>
           <a:p>
-            <a:pPr algn="l">
+            <a:pPr algn="l" marL="0" indent="0">
+              <a:buNone/>
               <a:defRPr sz="2400" b="0">
                 <a:solidFill>
                   <a:srgbClr val="423C3B"/>
@@ -17155,12 +17448,16 @@
             </a:r>
           </a:p>
           <a:p>
+            <a:pPr marL="0" indent="0">
+              <a:buNone/>
+            </a:pPr>
             <a:r>
               <a:t/>
             </a:r>
           </a:p>
           <a:p>
-            <a:pPr algn="l">
+            <a:pPr algn="l" marL="0" indent="0">
+              <a:buNone/>
               <a:defRPr sz="2400" b="0">
                 <a:solidFill>
                   <a:srgbClr val="423C3B"/>
@@ -17183,12 +17480,16 @@
             </a:r>
           </a:p>
           <a:p>
+            <a:pPr marL="0" indent="0">
+              <a:buNone/>
+            </a:pPr>
             <a:r>
               <a:t/>
             </a:r>
           </a:p>
           <a:p>
-            <a:pPr algn="l">
+            <a:pPr algn="l" marL="0" indent="0">
+              <a:buNone/>
               <a:defRPr sz="2400" b="0">
                 <a:solidFill>
                   <a:srgbClr val="423C3B"/>
@@ -17247,7 +17548,8 @@
           </a:bodyPr>
           <a:lstStyle/>
           <a:p>
-            <a:pPr algn="l">
+            <a:pPr algn="l" marL="0" indent="0">
+              <a:buNone/>
               <a:defRPr sz="2400" b="0">
                 <a:solidFill>
                   <a:srgbClr val="423C3B"/>
@@ -17270,12 +17572,16 @@
             </a:r>
           </a:p>
           <a:p>
+            <a:pPr marL="0" indent="0">
+              <a:buNone/>
+            </a:pPr>
             <a:r>
               <a:t/>
             </a:r>
           </a:p>
           <a:p>
-            <a:pPr algn="l">
+            <a:pPr algn="l" marL="0" indent="0">
+              <a:buNone/>
               <a:defRPr sz="2400" b="0">
                 <a:solidFill>
                   <a:srgbClr val="423C3B"/>
@@ -17298,12 +17604,16 @@
             </a:r>
           </a:p>
           <a:p>
+            <a:pPr marL="0" indent="0">
+              <a:buNone/>
+            </a:pPr>
             <a:r>
               <a:t/>
             </a:r>
           </a:p>
           <a:p>
-            <a:pPr algn="l">
+            <a:pPr algn="l" marL="0" indent="0">
+              <a:buNone/>
               <a:defRPr sz="2400" b="0">
                 <a:solidFill>
                   <a:srgbClr val="423C3B"/>
@@ -17362,7 +17672,8 @@
           </a:bodyPr>
           <a:lstStyle/>
           <a:p>
-            <a:pPr algn="ctr">
+            <a:pPr algn="ctr" marL="0" indent="0">
+              <a:buNone/>
               <a:defRPr sz="1950" b="0">
                 <a:solidFill>
                   <a:srgbClr val="47171C"/>
@@ -17450,7 +17761,8 @@
           </a:bodyPr>
           <a:lstStyle/>
           <a:p>
-            <a:pPr algn="ctr">
+            <a:pPr algn="ctr" marL="0" indent="0">
+              <a:buNone/>
               <a:defRPr sz="5250" b="1">
                 <a:solidFill>
                   <a:srgbClr val="47171C"/>
@@ -17509,7 +17821,8 @@
           </a:bodyPr>
           <a:lstStyle/>
           <a:p>
-            <a:pPr algn="ctr">
+            <a:pPr algn="ctr" marL="0" indent="0">
+              <a:buNone/>
               <a:defRPr sz="2175" b="0">
                 <a:solidFill>
                   <a:srgbClr val="423C3B"/>
@@ -17568,7 +17881,8 @@
           </a:bodyPr>
           <a:lstStyle/>
           <a:p>
-            <a:pPr algn="ctr">
+            <a:pPr algn="ctr" marL="0" indent="0">
+              <a:buNone/>
               <a:defRPr sz="2700" b="1">
                 <a:solidFill>
                   <a:srgbClr val="FCF8F5"/>
@@ -17627,7 +17941,8 @@
           </a:bodyPr>
           <a:lstStyle/>
           <a:p>
-            <a:pPr algn="l">
+            <a:pPr algn="l" marL="0" indent="0">
+              <a:buNone/>
               <a:defRPr sz="2700" b="1">
                 <a:solidFill>
                   <a:srgbClr val="47171C"/>
@@ -17686,7 +18001,8 @@
           </a:bodyPr>
           <a:lstStyle/>
           <a:p>
-            <a:pPr algn="l">
+            <a:pPr algn="l" marL="0" indent="0">
+              <a:buNone/>
               <a:defRPr sz="2250" b="0">
                 <a:solidFill>
                   <a:srgbClr val="423C3B"/>
@@ -17745,7 +18061,8 @@
           </a:bodyPr>
           <a:lstStyle/>
           <a:p>
-            <a:pPr algn="ctr">
+            <a:pPr algn="ctr" marL="0" indent="0">
+              <a:buNone/>
               <a:defRPr sz="2700" b="1">
                 <a:solidFill>
                   <a:srgbClr val="FCF8F5"/>
@@ -17804,7 +18121,8 @@
           </a:bodyPr>
           <a:lstStyle/>
           <a:p>
-            <a:pPr algn="l">
+            <a:pPr algn="l" marL="0" indent="0">
+              <a:buNone/>
               <a:defRPr sz="2700" b="1">
                 <a:solidFill>
                   <a:srgbClr val="47171C"/>
@@ -17863,7 +18181,8 @@
           </a:bodyPr>
           <a:lstStyle/>
           <a:p>
-            <a:pPr algn="l">
+            <a:pPr algn="l" marL="0" indent="0">
+              <a:buNone/>
               <a:defRPr sz="2250" b="0">
                 <a:solidFill>
                   <a:srgbClr val="423C3B"/>
@@ -17922,7 +18241,8 @@
           </a:bodyPr>
           <a:lstStyle/>
           <a:p>
-            <a:pPr algn="ctr">
+            <a:pPr algn="ctr" marL="0" indent="0">
+              <a:buNone/>
               <a:defRPr sz="2700" b="1">
                 <a:solidFill>
                   <a:srgbClr val="FCF8F5"/>
@@ -17981,7 +18301,8 @@
           </a:bodyPr>
           <a:lstStyle/>
           <a:p>
-            <a:pPr algn="l">
+            <a:pPr algn="l" marL="0" indent="0">
+              <a:buNone/>
               <a:defRPr sz="2700" b="1">
                 <a:solidFill>
                   <a:srgbClr val="47171C"/>
@@ -18040,7 +18361,8 @@
           </a:bodyPr>
           <a:lstStyle/>
           <a:p>
-            <a:pPr algn="l">
+            <a:pPr algn="l" marL="0" indent="0">
+              <a:buNone/>
               <a:defRPr sz="2250" b="0">
                 <a:solidFill>
                   <a:srgbClr val="423C3B"/>
@@ -18099,7 +18421,8 @@
           </a:bodyPr>
           <a:lstStyle/>
           <a:p>
-            <a:pPr algn="ctr">
+            <a:pPr algn="ctr" marL="0" indent="0">
+              <a:buNone/>
               <a:defRPr sz="2700" b="1">
                 <a:solidFill>
                   <a:srgbClr val="FCF8F5"/>
@@ -18158,7 +18481,8 @@
           </a:bodyPr>
           <a:lstStyle/>
           <a:p>
-            <a:pPr algn="l">
+            <a:pPr algn="l" marL="0" indent="0">
+              <a:buNone/>
               <a:defRPr sz="2700" b="1">
                 <a:solidFill>
                   <a:srgbClr val="47171C"/>
@@ -18217,7 +18541,8 @@
           </a:bodyPr>
           <a:lstStyle/>
           <a:p>
-            <a:pPr algn="l">
+            <a:pPr algn="l" marL="0" indent="0">
+              <a:buNone/>
               <a:defRPr sz="2250" b="0">
                 <a:solidFill>
                   <a:srgbClr val="423C3B"/>
@@ -18276,7 +18601,8 @@
           </a:bodyPr>
           <a:lstStyle/>
           <a:p>
-            <a:pPr algn="ctr">
+            <a:pPr algn="ctr" marL="0" indent="0">
+              <a:buNone/>
               <a:defRPr sz="2025" b="0">
                 <a:solidFill>
                   <a:srgbClr val="CF8792"/>

</xml_diff>